<commit_message>
solve space problem in title
</commit_message>
<xml_diff>
--- a/Documents/Newsletter v4.pptx
+++ b/Documents/Newsletter v4.pptx
@@ -265,7 +265,7 @@
           <a:p>
             <a:fld id="{79A50466-656F-490F-AF25-ED87A19EECF4}" type="datetimeFigureOut">
               <a:rPr lang="es-ES" smtClean="0"/>
-              <a:t>09/03/2026</a:t>
+              <a:t>20/06/2026</a:t>
             </a:fld>
             <a:endParaRPr lang="es-ES"/>
           </a:p>
@@ -463,7 +463,7 @@
           <a:p>
             <a:fld id="{79A50466-656F-490F-AF25-ED87A19EECF4}" type="datetimeFigureOut">
               <a:rPr lang="es-ES" smtClean="0"/>
-              <a:t>09/03/2026</a:t>
+              <a:t>20/06/2026</a:t>
             </a:fld>
             <a:endParaRPr lang="es-ES"/>
           </a:p>
@@ -671,7 +671,7 @@
           <a:p>
             <a:fld id="{79A50466-656F-490F-AF25-ED87A19EECF4}" type="datetimeFigureOut">
               <a:rPr lang="es-ES" smtClean="0"/>
-              <a:t>09/03/2026</a:t>
+              <a:t>20/06/2026</a:t>
             </a:fld>
             <a:endParaRPr lang="es-ES"/>
           </a:p>
@@ -869,7 +869,7 @@
           <a:p>
             <a:fld id="{79A50466-656F-490F-AF25-ED87A19EECF4}" type="datetimeFigureOut">
               <a:rPr lang="es-ES" smtClean="0"/>
-              <a:t>09/03/2026</a:t>
+              <a:t>20/06/2026</a:t>
             </a:fld>
             <a:endParaRPr lang="es-ES"/>
           </a:p>
@@ -1144,7 +1144,7 @@
           <a:p>
             <a:fld id="{79A50466-656F-490F-AF25-ED87A19EECF4}" type="datetimeFigureOut">
               <a:rPr lang="es-ES" smtClean="0"/>
-              <a:t>09/03/2026</a:t>
+              <a:t>20/06/2026</a:t>
             </a:fld>
             <a:endParaRPr lang="es-ES"/>
           </a:p>
@@ -1409,7 +1409,7 @@
           <a:p>
             <a:fld id="{79A50466-656F-490F-AF25-ED87A19EECF4}" type="datetimeFigureOut">
               <a:rPr lang="es-ES" smtClean="0"/>
-              <a:t>09/03/2026</a:t>
+              <a:t>20/06/2026</a:t>
             </a:fld>
             <a:endParaRPr lang="es-ES"/>
           </a:p>
@@ -1821,7 +1821,7 @@
           <a:p>
             <a:fld id="{79A50466-656F-490F-AF25-ED87A19EECF4}" type="datetimeFigureOut">
               <a:rPr lang="es-ES" smtClean="0"/>
-              <a:t>09/03/2026</a:t>
+              <a:t>20/06/2026</a:t>
             </a:fld>
             <a:endParaRPr lang="es-ES"/>
           </a:p>
@@ -1962,7 +1962,7 @@
           <a:p>
             <a:fld id="{79A50466-656F-490F-AF25-ED87A19EECF4}" type="datetimeFigureOut">
               <a:rPr lang="es-ES" smtClean="0"/>
-              <a:t>09/03/2026</a:t>
+              <a:t>20/06/2026</a:t>
             </a:fld>
             <a:endParaRPr lang="es-ES"/>
           </a:p>
@@ -2075,7 +2075,7 @@
           <a:p>
             <a:fld id="{79A50466-656F-490F-AF25-ED87A19EECF4}" type="datetimeFigureOut">
               <a:rPr lang="es-ES" smtClean="0"/>
-              <a:t>09/03/2026</a:t>
+              <a:t>20/06/2026</a:t>
             </a:fld>
             <a:endParaRPr lang="es-ES"/>
           </a:p>
@@ -2386,7 +2386,7 @@
           <a:p>
             <a:fld id="{79A50466-656F-490F-AF25-ED87A19EECF4}" type="datetimeFigureOut">
               <a:rPr lang="es-ES" smtClean="0"/>
-              <a:t>09/03/2026</a:t>
+              <a:t>20/06/2026</a:t>
             </a:fld>
             <a:endParaRPr lang="es-ES"/>
           </a:p>
@@ -2674,7 +2674,7 @@
           <a:p>
             <a:fld id="{79A50466-656F-490F-AF25-ED87A19EECF4}" type="datetimeFigureOut">
               <a:rPr lang="es-ES" smtClean="0"/>
-              <a:t>09/03/2026</a:t>
+              <a:t>20/06/2026</a:t>
             </a:fld>
             <a:endParaRPr lang="es-ES"/>
           </a:p>
@@ -2915,7 +2915,7 @@
           <a:p>
             <a:fld id="{79A50466-656F-490F-AF25-ED87A19EECF4}" type="datetimeFigureOut">
               <a:rPr lang="es-ES" smtClean="0"/>
-              <a:t>09/03/2026</a:t>
+              <a:t>20/06/2026</a:t>
             </a:fld>
             <a:endParaRPr lang="es-ES"/>
           </a:p>
@@ -3698,8 +3698,8 @@
         </p:nvSpPr>
         <p:spPr>
           <a:xfrm>
-            <a:off x="9608825" y="2579623"/>
-            <a:ext cx="2111315" cy="430887"/>
+            <a:off x="9516732" y="2551348"/>
+            <a:ext cx="2111315" cy="261610"/>
           </a:xfrm>
           <a:prstGeom prst="rect">
             <a:avLst/>
@@ -3711,15 +3711,6 @@
             <a:spAutoFit/>
           </a:bodyPr>
           <a:lstStyle/>
-          <a:p>
-            <a:pPr algn="ctr"/>
-            <a:r>
-              <a:rPr lang="es-ES" sz="1100" dirty="0">
-                <a:hlinkClick r:id="rId3"/>
-              </a:rPr>
-              <a:t>activitats@aster.cat</a:t>
-            </a:r>
-          </a:p>
           <a:p>
             <a:pPr algn="ctr"/>
             <a:r>
@@ -6340,7 +6331,7 @@
         </p:blipFill>
         <p:spPr>
           <a:xfrm>
-            <a:off x="2326362" y="1914971"/>
+            <a:off x="2640687" y="2311832"/>
             <a:ext cx="6656111" cy="3028057"/>
           </a:xfrm>
           <a:prstGeom prst="rect">

</xml_diff>